<commit_message>
docs: actualiza presentaciones y agrega resumen en 10 diapositivas
Las presentaciones incluyen el modulo de pagos y el resumen explica el problema, la solucion y el funcionamiento del codigo.
</commit_message>
<xml_diff>
--- a/sigem/docs/SIGEM_Presentacion.pptx
+++ b/sigem/docs/SIGEM_Presentacion.pptx
@@ -115,35 +115,35 @@
   <p:extLst>
     <p:ext uri="{521415D9-36F7-43E2-AB2F-B90AF26B5E84}">
       <p14:sectionLst xmlns:p14="http://schemas.microsoft.com/office/powerpoint/2010/main">
-        <p14:section name="Portada" id="{a75e9fdb-8e41-59da-43f4-6f2e20ab9a73}">
+        <p14:section name="Portada" id="{6c817b49-29da-199b-fbdf-e585b22aac62}">
           <p14:sldIdLst>
             <p14:sldId id="256"/>
           </p14:sldIdLst>
         </p14:section>
-        <p14:section name="Arquitectura" id="{851d0d3c-9a7b-6f9f-19cc-3f071e70ed8f}">
+        <p14:section name="Arquitectura" id="{f38486f3-63e3-10f5-a86b-c0593be99e56}">
           <p14:sldIdLst>
             <p14:sldId id="257"/>
           </p14:sldIdLst>
         </p14:section>
-        <p14:section name="Interfaces UX/UI" id="{0163d10b-3af9-8791-ff39-6303b1a8c780}">
+        <p14:section name="Interfaces UX/UI" id="{9f8c2c61-867d-5357-daca-bacbcd4228e8}">
           <p14:sldIdLst>
             <p14:sldId id="258"/>
             <p14:sldId id="259"/>
           </p14:sldIdLst>
         </p14:section>
-        <p14:section name="Clases y mantenimientos" id="{b0ac61e7-6c07-e53d-f026-f36ae384246c}">
+        <p14:section name="Clases y mantenimientos" id="{21e6ea40-726f-6332-630d-efdd1694c5ee}">
           <p14:sldIdLst>
             <p14:sldId id="260"/>
             <p14:sldId id="261"/>
           </p14:sldIdLst>
         </p14:section>
-        <p14:section name="Respaldo y BBDD" id="{59a2d625-53cb-a7e4-1f3b-fa776f95df4e}">
+        <p14:section name="Respaldo y BBDD" id="{4a714ba1-dc11-06c7-6a27-b378ff8ac8ee}">
           <p14:sldIdLst>
             <p14:sldId id="262"/>
             <p14:sldId id="263"/>
           </p14:sldIdLst>
         </p14:section>
-        <p14:section name="Cierre" id="{b1c45712-7155-9f1f-3a52-ffa1f4cca145}">
+        <p14:section name="Cierre" id="{514e84a9-9cee-f841-5d27-90f6ac14afd9}">
           <p14:sldIdLst>
             <p14:sldId id="264"/>
           </p14:sldIdLst>
@@ -1256,7 +1256,7 @@
           <a:p>
             <a:r>
               <a:rPr lang="en-US" dirty="0"/>
-              <a:t>En resumen: implementamos los 18 requisitos funcionales, con 43 pruebas automatizadas en verde, 45 tablas en PostgreSQL y 8 roles. La arquitectura en capas con DTO, DAO y SOLID nos permitió agregar auditoría y respaldos sin romper lo existente. Gracias, quedamos atentos a sus preguntas.</a:t>
+              <a:t>En resumen: implementamos los 18 requisitos funcionales, con 63 pruebas automatizadas en verde, 46 tablas en PostgreSQL y 8 roles. La arquitectura en capas con DTO, DAO y SOLID nos permitió agregar auditoría y respaldos sin romper lo existente. Gracias, quedamos atentos a sus preguntas.</a:t>
             </a:r>
             <a:endParaRPr lang="en-US" dirty="0"/>
           </a:p>
@@ -2235,7 +2235,7 @@
                   <a:schemeClr val="tx1"/>
                 </a:solidFill>
               </a:rPr>
-              <a:t>Hilaccama Choque, Sujey Yliana</a:t>
+              <a:t>Mamani Vargas, Abel Valerio</a:t>
             </a:r>
             <a:endParaRPr lang="en-US" sz="1400" dirty="0"/>
           </a:p>
@@ -2249,7 +2249,7 @@
                   <a:schemeClr val="accent5"/>
                 </a:solidFill>
               </a:rPr>
-              <a:t>CUI U23241152</a:t>
+              <a:t>CUI U21304236</a:t>
             </a:r>
             <a:endParaRPr lang="en-US" sz="1400" dirty="0"/>
           </a:p>
@@ -2285,7 +2285,7 @@
                   <a:schemeClr val="tx1"/>
                 </a:solidFill>
               </a:rPr>
-              <a:t>Mamani Vargas, Abel Valerio</a:t>
+              <a:t>Rodriguez Huillca, Juan Ronaldo</a:t>
             </a:r>
             <a:endParaRPr lang="en-US" sz="1400" dirty="0"/>
           </a:p>
@@ -2299,7 +2299,7 @@
                   <a:schemeClr val="accent5"/>
                 </a:solidFill>
               </a:rPr>
-              <a:t>CUI U21304236</a:t>
+              <a:t>CUI U22207879</a:t>
             </a:r>
             <a:endParaRPr lang="en-US" sz="1400" dirty="0"/>
           </a:p>
@@ -2307,57 +2307,7 @@
       </p:sp>
       <p:sp>
         <p:nvSpPr>
-          <p:cNvPr id="13" name="integrante 3"/>
-          <p:cNvSpPr txBox="1"/>
-          <p:nvPr/>
-        </p:nvSpPr>
-        <p:spPr>
-          <a:xfrm>
-            <a:off x="7909560" y="3968496"/>
-            <a:ext cx="3429000" cy="566928"/>
-          </a:xfrm>
-          <a:prstGeom prst="rect">
-            <a:avLst/>
-          </a:prstGeom>
-          <a:noFill/>
-          <a:ln/>
-        </p:spPr>
-        <p:txBody>
-          <a:bodyPr wrap="square" lIns="0" tIns="0" rIns="0" bIns="0" rtlCol="0" anchor="t"/>
-          <a:lstStyle/>
-          <a:p>
-            <a:pPr indent="0" marL="0">
-              <a:buNone/>
-            </a:pPr>
-            <a:r>
-              <a:rPr lang="en-US" sz="1400" b="1" dirty="0">
-                <a:solidFill>
-                  <a:schemeClr val="tx1"/>
-                </a:solidFill>
-              </a:rPr>
-              <a:t>Rodriguez Huillca, Juan Ronaldo</a:t>
-            </a:r>
-            <a:endParaRPr lang="en-US" sz="1400" dirty="0"/>
-          </a:p>
-          <a:p>
-            <a:pPr indent="0" marL="0">
-              <a:buNone/>
-            </a:pPr>
-            <a:r>
-              <a:rPr lang="en-US" sz="1100" dirty="0">
-                <a:solidFill>
-                  <a:schemeClr val="accent5"/>
-                </a:solidFill>
-              </a:rPr>
-              <a:t>CUI U22207879</a:t>
-            </a:r>
-            <a:endParaRPr lang="en-US" sz="1400" dirty="0"/>
-          </a:p>
-        </p:txBody>
-      </p:sp>
-      <p:sp>
-        <p:nvSpPr>
-          <p:cNvPr id="14" name="docente"/>
+          <p:cNvPr id="13" name="docente"/>
           <p:cNvSpPr txBox="1"/>
           <p:nvPr/>
         </p:nvSpPr>
@@ -2667,7 +2617,7 @@
                   <a:schemeClr val="tx1"/>
                 </a:solidFill>
               </a:rPr>
-              <a:t>Thymeleaf: 94 vistas por área</a:t>
+              <a:t>Thymeleaf: 97 vistas por área</a:t>
             </a:r>
             <a:endParaRPr lang="en-US" sz="1500" dirty="0"/>
           </a:p>
@@ -6198,7 +6148,7 @@
                 <a:ea typeface="Arial" pitchFamily="34" charset="-122"/>
                 <a:cs typeface="Arial" pitchFamily="34" charset="-120"/>
               </a:rPr>
-              <a:t>43</a:t>
+              <a:t>63</a:t>
             </a:r>
             <a:endParaRPr lang="en-US" sz="6600" dirty="0"/>
           </a:p>
@@ -6273,7 +6223,7 @@
                 <a:ea typeface="Arial" pitchFamily="34" charset="-122"/>
                 <a:cs typeface="Arial" pitchFamily="34" charset="-120"/>
               </a:rPr>
-              <a:t>45</a:t>
+              <a:t>46</a:t>
             </a:r>
             <a:endParaRPr lang="en-US" sz="6600" dirty="0"/>
           </a:p>

</xml_diff>